<commit_message>
Put operational excellence last in the outcome sequence.
Guests, ratings, and income come first. Operational excellence is what the portfolio arrives at.

Co-authored-by: shervin <shervin@mench.com>
</commit_message>
<xml_diff>
--- a/public/pitch-deck.pptx
+++ b/public/pitch-deck.pptx
@@ -2750,7 +2750,7 @@
                 <a:ea typeface="Calibri" pitchFamily="34" charset="-122"/>
                 <a:cs typeface="Calibri" pitchFamily="34" charset="-120"/>
               </a:rPr>
-              <a:t>Operational excellence across the portfolio.</a:t>
+              <a:t>Guests who feel looked after, not queued.</a:t>
             </a:r>
             <a:endParaRPr lang="en-US" sz="1800" dirty="0"/>
           </a:p>
@@ -2770,7 +2770,7 @@
                 <a:ea typeface="Calibri" pitchFamily="34" charset="-122"/>
                 <a:cs typeface="Calibri" pitchFamily="34" charset="-120"/>
               </a:rPr>
-              <a:t>Guests who feel looked after, not queued.</a:t>
+              <a:t>Average ratings that rise as the loop gets tighter.</a:t>
             </a:r>
             <a:endParaRPr lang="en-US" sz="1800" dirty="0"/>
           </a:p>
@@ -2790,7 +2790,7 @@
                 <a:ea typeface="Calibri" pitchFamily="34" charset="-122"/>
                 <a:cs typeface="Calibri" pitchFamily="34" charset="-120"/>
               </a:rPr>
-              <a:t>Average ratings that rise as the loop gets tighter.</a:t>
+              <a:t>Higher income from the listings the operator already has.</a:t>
             </a:r>
             <a:endParaRPr lang="en-US" sz="1800" dirty="0"/>
           </a:p>
@@ -2810,7 +2810,7 @@
                 <a:ea typeface="Calibri" pitchFamily="34" charset="-122"/>
                 <a:cs typeface="Calibri" pitchFamily="34" charset="-120"/>
               </a:rPr>
-              <a:t>Higher income from the listings the operator already has.</a:t>
+              <a:t>Operational excellence across the portfolio, once the rest is in place.</a:t>
             </a:r>
             <a:endParaRPr lang="en-US" sz="1800" dirty="0"/>
           </a:p>

</xml_diff>